<commit_message>
Update school presentations and add new files
</commit_message>
<xml_diff>
--- a/paidagogiko/ΠΡΥ 004-1 - Αξιολόγηση μάθησης στη Δευτεροβάθμια Εκπαίδευση/Αξιολόγηση του Μαθητή - meetings 3-5.pptx
+++ b/paidagogiko/ΠΡΥ 004-1 - Αξιολόγηση μάθησης στη Δευτεροβάθμια Εκπαίδευση/Αξιολόγηση του Μαθητή - meetings 3-5.pptx
@@ -191,6 +191,35 @@
     </p:ext>
   </p:extLst>
 </p:presentation>
+</file>
+
+<file path=ppt/changesInfos/changesInfo1.xml><?xml version="1.0" encoding="utf-8"?>
+<pc:chgInfo xmlns:a="http://schemas.openxmlformats.org/drawingml/2006/main" xmlns:r="http://schemas.openxmlformats.org/officeDocument/2006/relationships" xmlns:ac="http://schemas.microsoft.com/office/drawing/2013/main/command" xmlns:pc="http://schemas.microsoft.com/office/powerpoint/2013/main/command">
+  <pc:docChgLst>
+    <pc:chgData name="Άριστος Αρέστη" userId="813aa191-2d4c-464f-9d05-0a7e494d859f" providerId="ADAL" clId="{49C7B61D-1ACF-4AFF-A04E-A3B433E32474}"/>
+    <pc:docChg chg="modSld">
+      <pc:chgData name="Άριστος Αρέστη" userId="813aa191-2d4c-464f-9d05-0a7e494d859f" providerId="ADAL" clId="{49C7B61D-1ACF-4AFF-A04E-A3B433E32474}" dt="2026-10-23T05:30:06.858" v="0" actId="123"/>
+      <pc:docMkLst>
+        <pc:docMk/>
+      </pc:docMkLst>
+      <pc:sldChg chg="modSp mod">
+        <pc:chgData name="Άριστος Αρέστη" userId="813aa191-2d4c-464f-9d05-0a7e494d859f" providerId="ADAL" clId="{49C7B61D-1ACF-4AFF-A04E-A3B433E32474}" dt="2026-10-23T05:30:06.858" v="0" actId="123"/>
+        <pc:sldMkLst>
+          <pc:docMk/>
+          <pc:sldMk cId="0" sldId="379"/>
+        </pc:sldMkLst>
+        <pc:spChg chg="mod">
+          <ac:chgData name="Άριστος Αρέστη" userId="813aa191-2d4c-464f-9d05-0a7e494d859f" providerId="ADAL" clId="{49C7B61D-1ACF-4AFF-A04E-A3B433E32474}" dt="2026-10-23T05:30:06.858" v="0" actId="123"/>
+          <ac:spMkLst>
+            <pc:docMk/>
+            <pc:sldMk cId="0" sldId="379"/>
+            <ac:spMk id="2" creationId="{00000000-0000-0000-0000-000000000000}"/>
+          </ac:spMkLst>
+        </pc:spChg>
+      </pc:sldChg>
+    </pc:docChg>
+  </pc:docChgLst>
+</pc:chgInfo>
 </file>
 
 <file path=ppt/diagrams/colors1.xml><?xml version="1.0" encoding="utf-8"?>
@@ -3138,7 +3167,7 @@
             <a:fld id="{BA45DFB7-83FB-44C6-9FCE-AD0D0C313115}" type="datetimeFigureOut">
               <a:rPr lang="el-GR" smtClean="0"/>
               <a:pPr/>
-              <a:t>5/10/2026</a:t>
+              <a:t>23/10/2026</a:t>
             </a:fld>
             <a:endParaRPr lang="el-GR"/>
           </a:p>
@@ -3309,7 +3338,7 @@
             <a:fld id="{2A983513-E7BE-4C0A-B9EB-D39F627DF45B}" type="datetimeFigureOut">
               <a:rPr lang="el-GR" smtClean="0"/>
               <a:pPr/>
-              <a:t>5/10/2026</a:t>
+              <a:t>23/10/2026</a:t>
             </a:fld>
             <a:endParaRPr lang="el-GR"/>
           </a:p>
@@ -6082,7 +6111,7 @@
             <a:fld id="{9672EB40-6915-4CDE-8D7F-2613013208F9}" type="datetime1">
               <a:rPr lang="el-GR" smtClean="0"/>
               <a:pPr/>
-              <a:t>5/10/2026</a:t>
+              <a:t>23/10/2026</a:t>
             </a:fld>
             <a:endParaRPr lang="el-GR"/>
           </a:p>
@@ -6252,7 +6281,7 @@
             <a:fld id="{C255CCFF-50AF-4D42-828F-23E55564D38C}" type="datetime1">
               <a:rPr lang="el-GR" smtClean="0"/>
               <a:pPr/>
-              <a:t>5/10/2026</a:t>
+              <a:t>23/10/2026</a:t>
             </a:fld>
             <a:endParaRPr lang="el-GR"/>
           </a:p>
@@ -6432,7 +6461,7 @@
             <a:fld id="{3EEDCDC7-7622-4AE5-B6D6-133A574BE6AD}" type="datetime1">
               <a:rPr lang="el-GR" smtClean="0"/>
               <a:pPr/>
-              <a:t>5/10/2026</a:t>
+              <a:t>23/10/2026</a:t>
             </a:fld>
             <a:endParaRPr lang="el-GR"/>
           </a:p>
@@ -6674,7 +6703,7 @@
             <a:fld id="{FC6B7943-18F6-43D0-9D60-BEA541DFEE20}" type="datetime1">
               <a:rPr lang="el-GR" smtClean="0"/>
               <a:pPr/>
-              <a:t>5/10/2026</a:t>
+              <a:t>23/10/2026</a:t>
             </a:fld>
             <a:endParaRPr lang="el-GR"/>
           </a:p>
@@ -6844,7 +6873,7 @@
             <a:fld id="{34D6812F-02EB-4B75-95DB-1ECC7312BBBB}" type="datetime1">
               <a:rPr lang="el-GR" smtClean="0"/>
               <a:pPr/>
-              <a:t>5/10/2026</a:t>
+              <a:t>23/10/2026</a:t>
             </a:fld>
             <a:endParaRPr lang="el-GR"/>
           </a:p>
@@ -7090,7 +7119,7 @@
             <a:fld id="{BBC7CC61-2B8E-4DF7-9581-41DAB7030C13}" type="datetime1">
               <a:rPr lang="el-GR" smtClean="0"/>
               <a:pPr/>
-              <a:t>5/10/2026</a:t>
+              <a:t>23/10/2026</a:t>
             </a:fld>
             <a:endParaRPr lang="el-GR"/>
           </a:p>
@@ -7378,7 +7407,7 @@
             <a:fld id="{30C78E38-7D0D-4481-87E4-09A085112B80}" type="datetime1">
               <a:rPr lang="el-GR" smtClean="0"/>
               <a:pPr/>
-              <a:t>5/10/2026</a:t>
+              <a:t>23/10/2026</a:t>
             </a:fld>
             <a:endParaRPr lang="el-GR"/>
           </a:p>
@@ -7800,7 +7829,7 @@
             <a:fld id="{407B35FF-0850-43D7-9C26-03699985D73C}" type="datetime1">
               <a:rPr lang="el-GR" smtClean="0"/>
               <a:pPr/>
-              <a:t>5/10/2026</a:t>
+              <a:t>23/10/2026</a:t>
             </a:fld>
             <a:endParaRPr lang="el-GR"/>
           </a:p>
@@ -7918,7 +7947,7 @@
             <a:fld id="{D9383121-4790-40B0-89E0-EC564D0883CA}" type="datetime1">
               <a:rPr lang="el-GR" smtClean="0"/>
               <a:pPr/>
-              <a:t>5/10/2026</a:t>
+              <a:t>23/10/2026</a:t>
             </a:fld>
             <a:endParaRPr lang="el-GR"/>
           </a:p>
@@ -8013,7 +8042,7 @@
             <a:fld id="{42FFC1CA-7965-4D69-A6F9-E2B6F4ED7C40}" type="datetime1">
               <a:rPr lang="el-GR" smtClean="0"/>
               <a:pPr/>
-              <a:t>5/10/2026</a:t>
+              <a:t>23/10/2026</a:t>
             </a:fld>
             <a:endParaRPr lang="el-GR"/>
           </a:p>
@@ -8290,7 +8319,7 @@
             <a:fld id="{FFC2E8B6-FC98-41EE-B970-EDD3D6AFD464}" type="datetime1">
               <a:rPr lang="el-GR" smtClean="0"/>
               <a:pPr/>
-              <a:t>5/10/2026</a:t>
+              <a:t>23/10/2026</a:t>
             </a:fld>
             <a:endParaRPr lang="el-GR"/>
           </a:p>
@@ -8460,7 +8489,7 @@
             <a:fld id="{D55D03E4-A0D5-49E7-A3FE-E3D4F3CE508B}" type="datetime1">
               <a:rPr lang="el-GR" smtClean="0"/>
               <a:pPr/>
-              <a:t>5/10/2026</a:t>
+              <a:t>23/10/2026</a:t>
             </a:fld>
             <a:endParaRPr lang="el-GR"/>
           </a:p>
@@ -8713,7 +8742,7 @@
             <a:fld id="{8C6A8D13-F210-4C68-9FA1-DD66224D8F12}" type="datetime1">
               <a:rPr lang="el-GR" smtClean="0"/>
               <a:pPr/>
-              <a:t>5/10/2026</a:t>
+              <a:t>23/10/2026</a:t>
             </a:fld>
             <a:endParaRPr lang="el-GR"/>
           </a:p>
@@ -8883,7 +8912,7 @@
             <a:fld id="{9391DDFB-F982-46F1-9763-09BBED590EE2}" type="datetime1">
               <a:rPr lang="el-GR" smtClean="0"/>
               <a:pPr/>
-              <a:t>5/10/2026</a:t>
+              <a:t>23/10/2026</a:t>
             </a:fld>
             <a:endParaRPr lang="el-GR"/>
           </a:p>
@@ -9063,7 +9092,7 @@
             <a:fld id="{DD3097AE-E933-4BA0-AC1D-789310B86A2E}" type="datetime1">
               <a:rPr lang="el-GR" smtClean="0"/>
               <a:pPr/>
-              <a:t>5/10/2026</a:t>
+              <a:t>23/10/2026</a:t>
             </a:fld>
             <a:endParaRPr lang="el-GR"/>
           </a:p>
@@ -9265,7 +9294,7 @@
             <a:fld id="{D164A0DB-D085-44D6-BD98-104C6541C373}" type="datetime1">
               <a:rPr lang="el-GR" smtClean="0"/>
               <a:pPr/>
-              <a:t>5/10/2026</a:t>
+              <a:t>23/10/2026</a:t>
             </a:fld>
             <a:endParaRPr lang="el-GR" dirty="0"/>
           </a:p>
@@ -9582,7 +9611,7 @@
             <a:fld id="{3C4C6C0A-8B12-4FC3-B93A-B30D87696C89}" type="datetime1">
               <a:rPr lang="el-GR" smtClean="0"/>
               <a:pPr/>
-              <a:t>5/10/2026</a:t>
+              <a:t>23/10/2026</a:t>
             </a:fld>
             <a:endParaRPr lang="el-GR"/>
           </a:p>
@@ -9855,7 +9884,7 @@
             <a:fld id="{B52D9DA7-761D-47A8-9EA2-A13EA5642AB3}" type="datetime1">
               <a:rPr lang="el-GR" smtClean="0"/>
               <a:pPr/>
-              <a:t>5/10/2026</a:t>
+              <a:t>23/10/2026</a:t>
             </a:fld>
             <a:endParaRPr lang="el-GR"/>
           </a:p>
@@ -10079,7 +10108,7 @@
             <a:fld id="{85C7F1EC-FAEA-4048-9612-84F093FDE440}" type="datetime1">
               <a:rPr lang="el-GR" smtClean="0"/>
               <a:pPr/>
-              <a:t>5/10/2026</a:t>
+              <a:t>23/10/2026</a:t>
             </a:fld>
             <a:endParaRPr lang="el-GR"/>
           </a:p>
@@ -10435,7 +10464,7 @@
             <a:fld id="{D7395488-7143-4A62-9722-4F33A2F21588}" type="datetime1">
               <a:rPr lang="el-GR" smtClean="0"/>
               <a:pPr/>
-              <a:t>5/10/2026</a:t>
+              <a:t>23/10/2026</a:t>
             </a:fld>
             <a:endParaRPr lang="el-GR"/>
           </a:p>
@@ -10671,7 +10700,7 @@
             <a:fld id="{60D04C54-1DF6-4C2A-A5D4-E63324041ACD}" type="datetime1">
               <a:rPr lang="el-GR" smtClean="0"/>
               <a:pPr/>
-              <a:t>5/10/2026</a:t>
+              <a:t>23/10/2026</a:t>
             </a:fld>
             <a:endParaRPr lang="el-GR"/>
           </a:p>
@@ -10816,7 +10845,7 @@
             <a:fld id="{62A1E8AB-03F6-4160-8972-B1FB68939573}" type="datetime1">
               <a:rPr lang="el-GR" smtClean="0"/>
               <a:pPr/>
-              <a:t>5/10/2026</a:t>
+              <a:t>23/10/2026</a:t>
             </a:fld>
             <a:endParaRPr lang="el-GR"/>
           </a:p>
@@ -11148,7 +11177,7 @@
             <a:fld id="{07CEFE7F-C528-48C4-8FFF-C58A635B88A5}" type="datetime1">
               <a:rPr lang="el-GR" smtClean="0"/>
               <a:pPr/>
-              <a:t>5/10/2026</a:t>
+              <a:t>23/10/2026</a:t>
             </a:fld>
             <a:endParaRPr lang="el-GR"/>
           </a:p>
@@ -11343,7 +11372,7 @@
             <a:fld id="{680CEA98-2755-4194-BC12-6E801B56B4B0}" type="datetime1">
               <a:rPr lang="el-GR" smtClean="0"/>
               <a:pPr/>
-              <a:t>5/10/2026</a:t>
+              <a:t>23/10/2026</a:t>
             </a:fld>
             <a:endParaRPr lang="el-GR"/>
           </a:p>
@@ -11753,7 +11782,7 @@
             <a:fld id="{F8C5536D-64D6-4DAA-8D78-82CEBFE70CE8}" type="datetime1">
               <a:rPr lang="el-GR" smtClean="0"/>
               <a:pPr/>
-              <a:t>5/10/2026</a:t>
+              <a:t>23/10/2026</a:t>
             </a:fld>
             <a:endParaRPr lang="el-GR"/>
           </a:p>
@@ -12054,7 +12083,7 @@
             <a:fld id="{3A763C6C-41FA-4A83-A837-5B66B48C1741}" type="datetime1">
               <a:rPr lang="el-GR" smtClean="0"/>
               <a:pPr/>
-              <a:t>5/10/2026</a:t>
+              <a:t>23/10/2026</a:t>
             </a:fld>
             <a:endParaRPr lang="el-GR"/>
           </a:p>
@@ -12233,7 +12262,7 @@
             <a:fld id="{B3161AA2-D821-4BAE-8328-0B15479A0595}" type="datetime1">
               <a:rPr lang="el-GR" smtClean="0"/>
               <a:pPr/>
-              <a:t>5/10/2026</a:t>
+              <a:t>23/10/2026</a:t>
             </a:fld>
             <a:endParaRPr lang="el-GR"/>
           </a:p>
@@ -12473,7 +12502,7 @@
             <a:fld id="{6C93359C-AE47-4A93-83CF-A11221F281F3}" type="datetime1">
               <a:rPr lang="el-GR" smtClean="0"/>
               <a:pPr/>
-              <a:t>5/10/2026</a:t>
+              <a:t>23/10/2026</a:t>
             </a:fld>
             <a:endParaRPr lang="el-GR" dirty="0"/>
           </a:p>
@@ -12599,7 +12628,7 @@
             <a:fld id="{9C175A43-14D2-40E0-BE4A-D414131791CC}" type="datetime1">
               <a:rPr lang="el-GR" smtClean="0"/>
               <a:pPr/>
-              <a:t>5/10/2026</a:t>
+              <a:t>23/10/2026</a:t>
             </a:fld>
             <a:endParaRPr lang="el-GR" dirty="0"/>
           </a:p>
@@ -12895,7 +12924,7 @@
             <a:fld id="{5E6B569D-704F-48D2-BF6B-E498BA495C53}" type="datetime1">
               <a:rPr lang="el-GR" smtClean="0"/>
               <a:pPr/>
-              <a:t>5/10/2026</a:t>
+              <a:t>23/10/2026</a:t>
             </a:fld>
             <a:endParaRPr lang="el-GR"/>
           </a:p>
@@ -13317,7 +13346,7 @@
             <a:fld id="{17FAD555-7D90-4363-8034-76F802B22D0A}" type="datetime1">
               <a:rPr lang="el-GR" smtClean="0"/>
               <a:pPr/>
-              <a:t>5/10/2026</a:t>
+              <a:t>23/10/2026</a:t>
             </a:fld>
             <a:endParaRPr lang="el-GR"/>
           </a:p>
@@ -13435,7 +13464,7 @@
             <a:fld id="{858F7D9B-EDBF-4FF4-956D-3153DFD48705}" type="datetime1">
               <a:rPr lang="el-GR" smtClean="0"/>
               <a:pPr/>
-              <a:t>5/10/2026</a:t>
+              <a:t>23/10/2026</a:t>
             </a:fld>
             <a:endParaRPr lang="el-GR"/>
           </a:p>
@@ -13530,7 +13559,7 @@
             <a:fld id="{03A66EE3-F381-4C38-AC81-93FA487C1F80}" type="datetime1">
               <a:rPr lang="el-GR" smtClean="0"/>
               <a:pPr/>
-              <a:t>5/10/2026</a:t>
+              <a:t>23/10/2026</a:t>
             </a:fld>
             <a:endParaRPr lang="el-GR"/>
           </a:p>
@@ -13807,7 +13836,7 @@
             <a:fld id="{EDDCB2F4-5F83-4451-BCF1-51EAC2F08DF2}" type="datetime1">
               <a:rPr lang="el-GR" smtClean="0"/>
               <a:pPr/>
-              <a:t>5/10/2026</a:t>
+              <a:t>23/10/2026</a:t>
             </a:fld>
             <a:endParaRPr lang="el-GR"/>
           </a:p>
@@ -14060,7 +14089,7 @@
             <a:fld id="{EFEA4120-2FE7-449D-B937-D939E079CD7C}" type="datetime1">
               <a:rPr lang="el-GR" smtClean="0"/>
               <a:pPr/>
-              <a:t>5/10/2026</a:t>
+              <a:t>23/10/2026</a:t>
             </a:fld>
             <a:endParaRPr lang="el-GR"/>
           </a:p>
@@ -14273,7 +14302,7 @@
             <a:fld id="{1BB6D28C-1FFF-4BA8-8EC7-0153C95EC979}" type="datetime1">
               <a:rPr lang="el-GR" smtClean="0"/>
               <a:pPr/>
-              <a:t>5/10/2026</a:t>
+              <a:t>23/10/2026</a:t>
             </a:fld>
             <a:endParaRPr lang="el-GR"/>
           </a:p>
@@ -14784,7 +14813,7 @@
             <a:fld id="{4F91778A-207F-44D4-947D-602BA6EBB835}" type="datetime1">
               <a:rPr lang="el-GR" smtClean="0"/>
               <a:pPr/>
-              <a:t>5/10/2026</a:t>
+              <a:t>23/10/2026</a:t>
             </a:fld>
             <a:endParaRPr lang="el-GR"/>
           </a:p>
@@ -15291,7 +15320,7 @@
             <a:fld id="{26AC9EC7-4DAE-4644-AE7F-891074F8480F}" type="datetime1">
               <a:rPr lang="el-GR" smtClean="0"/>
               <a:pPr/>
-              <a:t>5/10/2026</a:t>
+              <a:t>23/10/2026</a:t>
             </a:fld>
             <a:endParaRPr lang="el-GR"/>
           </a:p>
@@ -20376,7 +20405,7 @@
           </a:bodyPr>
           <a:lstStyle/>
           <a:p>
-            <a:pPr eaLnBrk="1" fontAlgn="auto">
+            <a:pPr algn="just" eaLnBrk="1" fontAlgn="auto">
               <a:spcAft>
                 <a:spcPts val="0"/>
               </a:spcAft>

</xml_diff>